<commit_message>
Presentation quality overhaul: 6 -> 16 themes, real gradient+grid+glow backgrounds (was flat fills)
Addresses feedback that the deck looked template-y: every theme now
renders a generated background (linear gradient + faint engineering grid
+ soft glow blobs in the accent colors) instead of a solid fill, stamped
as a full-bleed image behind each slide. HTML preview's CSS updated to
match. Hero slides (title/section/closing) get bolder glow; content
slides keep it subtle in a back corner so text stays legible.
</commit_message>
<xml_diff>
--- a/skills/premium-presentations/demo/sample.pptx
+++ b/skills/premium-presentations/demo/sample.pptx
@@ -3089,14 +3089,6 @@
 <file path=ppt/slides/slide1.xml><?xml version="1.0" encoding="utf-8"?>
 <p:sld xmlns:a="http://schemas.openxmlformats.org/drawingml/2006/main" xmlns:p="http://schemas.openxmlformats.org/presentationml/2006/main" xmlns:r="http://schemas.openxmlformats.org/officeDocument/2006/relationships">
   <p:cSld>
-    <p:bg>
-      <p:bgPr>
-        <a:solidFill>
-          <a:srgbClr val="12141C"/>
-        </a:solidFill>
-        <a:effectLst/>
-      </p:bgPr>
-    </p:bg>
     <p:spTree>
       <p:nvGrpSpPr>
         <p:cNvPr id="1" name=""/>
@@ -3104,9 +3096,33 @@
         <p:nvPr/>
       </p:nvGrpSpPr>
       <p:grpSpPr/>
-      <p:sp>
-        <p:nvSpPr>
-          <p:cNvPr id="2" name="TextBox 1"/>
+      <p:pic>
+        <p:nvPicPr>
+          <p:cNvPr id="2" name="Picture 1" descr="onyx-gold_hero.png"/>
+          <p:cNvPicPr>
+            <a:picLocks noChangeAspect="1"/>
+          </p:cNvPicPr>
+          <p:nvPr/>
+        </p:nvPicPr>
+        <p:blipFill>
+          <a:blip r:embed="rId2"/>
+          <a:stretch>
+            <a:fillRect/>
+          </a:stretch>
+        </p:blipFill>
+        <p:spPr>
+          <a:xfrm>
+            <a:off x="0" y="0"/>
+            <a:ext cx="12191695" cy="6858000"/>
+          </a:xfrm>
+          <a:prstGeom prst="rect">
+            <a:avLst/>
+          </a:prstGeom>
+        </p:spPr>
+      </p:pic>
+      <p:sp>
+        <p:nvSpPr>
+          <p:cNvPr id="3" name="TextBox 2"/>
           <p:cNvSpPr txBox="1"/>
           <p:nvPr/>
         </p:nvSpPr>
@@ -3140,7 +3156,7 @@
       </p:sp>
       <p:sp>
         <p:nvSpPr>
-          <p:cNvPr id="3" name="TextBox 2"/>
+          <p:cNvPr id="4" name="TextBox 3"/>
           <p:cNvSpPr txBox="1"/>
           <p:nvPr/>
         </p:nvSpPr>
@@ -3174,7 +3190,7 @@
       </p:sp>
       <p:sp>
         <p:nvSpPr>
-          <p:cNvPr id="4" name="TextBox 3"/>
+          <p:cNvPr id="5" name="TextBox 4"/>
           <p:cNvSpPr txBox="1"/>
           <p:nvPr/>
         </p:nvSpPr>
@@ -3208,7 +3224,7 @@
       </p:sp>
       <p:sp>
         <p:nvSpPr>
-          <p:cNvPr id="5" name="Rectangle 4"/>
+          <p:cNvPr id="6" name="Rectangle 5"/>
           <p:cNvSpPr/>
           <p:nvPr/>
         </p:nvSpPr>
@@ -3264,14 +3280,6 @@
 <file path=ppt/slides/slide2.xml><?xml version="1.0" encoding="utf-8"?>
 <p:sld xmlns:a="http://schemas.openxmlformats.org/drawingml/2006/main" xmlns:p="http://schemas.openxmlformats.org/presentationml/2006/main" xmlns:r="http://schemas.openxmlformats.org/officeDocument/2006/relationships">
   <p:cSld>
-    <p:bg>
-      <p:bgPr>
-        <a:solidFill>
-          <a:srgbClr val="1B1E2B"/>
-        </a:solidFill>
-        <a:effectLst/>
-      </p:bgPr>
-    </p:bg>
     <p:spTree>
       <p:nvGrpSpPr>
         <p:cNvPr id="1" name=""/>
@@ -3279,9 +3287,33 @@
         <p:nvPr/>
       </p:nvGrpSpPr>
       <p:grpSpPr/>
-      <p:sp>
-        <p:nvSpPr>
-          <p:cNvPr id="2" name="TextBox 1"/>
+      <p:pic>
+        <p:nvPicPr>
+          <p:cNvPr id="2" name="Picture 1" descr="onyx-gold_hero.png"/>
+          <p:cNvPicPr>
+            <a:picLocks noChangeAspect="1"/>
+          </p:cNvPicPr>
+          <p:nvPr/>
+        </p:nvPicPr>
+        <p:blipFill>
+          <a:blip r:embed="rId2"/>
+          <a:stretch>
+            <a:fillRect/>
+          </a:stretch>
+        </p:blipFill>
+        <p:spPr>
+          <a:xfrm>
+            <a:off x="0" y="0"/>
+            <a:ext cx="12191695" cy="6858000"/>
+          </a:xfrm>
+          <a:prstGeom prst="rect">
+            <a:avLst/>
+          </a:prstGeom>
+        </p:spPr>
+      </p:pic>
+      <p:sp>
+        <p:nvSpPr>
+          <p:cNvPr id="3" name="TextBox 2"/>
           <p:cNvSpPr txBox="1"/>
           <p:nvPr/>
         </p:nvSpPr>
@@ -3315,7 +3347,7 @@
       </p:sp>
       <p:sp>
         <p:nvSpPr>
-          <p:cNvPr id="3" name="TextBox 2"/>
+          <p:cNvPr id="4" name="TextBox 3"/>
           <p:cNvSpPr txBox="1"/>
           <p:nvPr/>
         </p:nvSpPr>
@@ -3349,7 +3381,7 @@
       </p:sp>
       <p:sp>
         <p:nvSpPr>
-          <p:cNvPr id="4" name="TextBox 3"/>
+          <p:cNvPr id="5" name="TextBox 4"/>
           <p:cNvSpPr txBox="1"/>
           <p:nvPr/>
         </p:nvSpPr>
@@ -3383,7 +3415,7 @@
       </p:sp>
       <p:sp>
         <p:nvSpPr>
-          <p:cNvPr id="5" name="TextBox 4"/>
+          <p:cNvPr id="6" name="TextBox 5"/>
           <p:cNvSpPr txBox="1"/>
           <p:nvPr/>
         </p:nvSpPr>
@@ -3429,14 +3461,6 @@
 <file path=ppt/slides/slide3.xml><?xml version="1.0" encoding="utf-8"?>
 <p:sld xmlns:a="http://schemas.openxmlformats.org/drawingml/2006/main" xmlns:p="http://schemas.openxmlformats.org/presentationml/2006/main" xmlns:r="http://schemas.openxmlformats.org/officeDocument/2006/relationships">
   <p:cSld>
-    <p:bg>
-      <p:bgPr>
-        <a:solidFill>
-          <a:srgbClr val="12141C"/>
-        </a:solidFill>
-        <a:effectLst/>
-      </p:bgPr>
-    </p:bg>
     <p:spTree>
       <p:nvGrpSpPr>
         <p:cNvPr id="1" name=""/>
@@ -3444,9 +3468,33 @@
         <p:nvPr/>
       </p:nvGrpSpPr>
       <p:grpSpPr/>
-      <p:sp>
-        <p:nvSpPr>
-          <p:cNvPr id="2" name="TextBox 1"/>
+      <p:pic>
+        <p:nvPicPr>
+          <p:cNvPr id="2" name="Picture 1" descr="onyx-gold_content.png"/>
+          <p:cNvPicPr>
+            <a:picLocks noChangeAspect="1"/>
+          </p:cNvPicPr>
+          <p:nvPr/>
+        </p:nvPicPr>
+        <p:blipFill>
+          <a:blip r:embed="rId2"/>
+          <a:stretch>
+            <a:fillRect/>
+          </a:stretch>
+        </p:blipFill>
+        <p:spPr>
+          <a:xfrm>
+            <a:off x="0" y="0"/>
+            <a:ext cx="12191695" cy="6858000"/>
+          </a:xfrm>
+          <a:prstGeom prst="rect">
+            <a:avLst/>
+          </a:prstGeom>
+        </p:spPr>
+      </p:pic>
+      <p:sp>
+        <p:nvSpPr>
+          <p:cNvPr id="3" name="TextBox 2"/>
           <p:cNvSpPr txBox="1"/>
           <p:nvPr/>
         </p:nvSpPr>
@@ -3480,7 +3528,7 @@
       </p:sp>
       <p:sp>
         <p:nvSpPr>
-          <p:cNvPr id="3" name="Rectangle 2"/>
+          <p:cNvPr id="4" name="Rectangle 3"/>
           <p:cNvSpPr/>
           <p:nvPr/>
         </p:nvSpPr>
@@ -3524,7 +3572,7 @@
       </p:sp>
       <p:sp>
         <p:nvSpPr>
-          <p:cNvPr id="4" name="TextBox 3"/>
+          <p:cNvPr id="5" name="TextBox 4"/>
           <p:cNvSpPr txBox="1"/>
           <p:nvPr/>
         </p:nvSpPr>
@@ -3558,7 +3606,7 @@
       </p:sp>
       <p:sp>
         <p:nvSpPr>
-          <p:cNvPr id="5" name="TextBox 4"/>
+          <p:cNvPr id="6" name="TextBox 5"/>
           <p:cNvSpPr txBox="1"/>
           <p:nvPr/>
         </p:nvSpPr>
@@ -3592,7 +3640,7 @@
       </p:sp>
       <p:sp>
         <p:nvSpPr>
-          <p:cNvPr id="6" name="TextBox 5"/>
+          <p:cNvPr id="7" name="TextBox 6"/>
           <p:cNvSpPr txBox="1"/>
           <p:nvPr/>
         </p:nvSpPr>
@@ -3626,7 +3674,7 @@
       </p:sp>
       <p:sp>
         <p:nvSpPr>
-          <p:cNvPr id="7" name="TextBox 6"/>
+          <p:cNvPr id="8" name="TextBox 7"/>
           <p:cNvSpPr txBox="1"/>
           <p:nvPr/>
         </p:nvSpPr>
@@ -3660,7 +3708,7 @@
       </p:sp>
       <p:sp>
         <p:nvSpPr>
-          <p:cNvPr id="8" name="TextBox 7"/>
+          <p:cNvPr id="9" name="TextBox 8"/>
           <p:cNvSpPr txBox="1"/>
           <p:nvPr/>
         </p:nvSpPr>
@@ -3694,7 +3742,7 @@
       </p:sp>
       <p:sp>
         <p:nvSpPr>
-          <p:cNvPr id="9" name="TextBox 8"/>
+          <p:cNvPr id="10" name="TextBox 9"/>
           <p:cNvSpPr txBox="1"/>
           <p:nvPr/>
         </p:nvSpPr>
@@ -3728,7 +3776,7 @@
       </p:sp>
       <p:sp>
         <p:nvSpPr>
-          <p:cNvPr id="10" name="TextBox 9"/>
+          <p:cNvPr id="11" name="TextBox 10"/>
           <p:cNvSpPr txBox="1"/>
           <p:nvPr/>
         </p:nvSpPr>
@@ -3762,7 +3810,7 @@
       </p:sp>
       <p:sp>
         <p:nvSpPr>
-          <p:cNvPr id="11" name="TextBox 10"/>
+          <p:cNvPr id="12" name="TextBox 11"/>
           <p:cNvSpPr txBox="1"/>
           <p:nvPr/>
         </p:nvSpPr>
@@ -3808,14 +3856,6 @@
 <file path=ppt/slides/slide4.xml><?xml version="1.0" encoding="utf-8"?>
 <p:sld xmlns:a="http://schemas.openxmlformats.org/drawingml/2006/main" xmlns:p="http://schemas.openxmlformats.org/presentationml/2006/main" xmlns:r="http://schemas.openxmlformats.org/officeDocument/2006/relationships">
   <p:cSld>
-    <p:bg>
-      <p:bgPr>
-        <a:solidFill>
-          <a:srgbClr val="12141C"/>
-        </a:solidFill>
-        <a:effectLst/>
-      </p:bgPr>
-    </p:bg>
     <p:spTree>
       <p:nvGrpSpPr>
         <p:cNvPr id="1" name=""/>
@@ -3823,9 +3863,33 @@
         <p:nvPr/>
       </p:nvGrpSpPr>
       <p:grpSpPr/>
-      <p:sp>
-        <p:nvSpPr>
-          <p:cNvPr id="2" name="TextBox 1"/>
+      <p:pic>
+        <p:nvPicPr>
+          <p:cNvPr id="2" name="Picture 1" descr="onyx-gold_content.png"/>
+          <p:cNvPicPr>
+            <a:picLocks noChangeAspect="1"/>
+          </p:cNvPicPr>
+          <p:nvPr/>
+        </p:nvPicPr>
+        <p:blipFill>
+          <a:blip r:embed="rId2"/>
+          <a:stretch>
+            <a:fillRect/>
+          </a:stretch>
+        </p:blipFill>
+        <p:spPr>
+          <a:xfrm>
+            <a:off x="0" y="0"/>
+            <a:ext cx="12191695" cy="6858000"/>
+          </a:xfrm>
+          <a:prstGeom prst="rect">
+            <a:avLst/>
+          </a:prstGeom>
+        </p:spPr>
+      </p:pic>
+      <p:sp>
+        <p:nvSpPr>
+          <p:cNvPr id="3" name="TextBox 2"/>
           <p:cNvSpPr txBox="1"/>
           <p:nvPr/>
         </p:nvSpPr>
@@ -3859,7 +3923,7 @@
       </p:sp>
       <p:sp>
         <p:nvSpPr>
-          <p:cNvPr id="3" name="Rectangle 2"/>
+          <p:cNvPr id="4" name="Rectangle 3"/>
           <p:cNvSpPr/>
           <p:nvPr/>
         </p:nvSpPr>
@@ -3903,7 +3967,7 @@
       </p:sp>
       <p:sp>
         <p:nvSpPr>
-          <p:cNvPr id="4" name="TextBox 3"/>
+          <p:cNvPr id="5" name="TextBox 4"/>
           <p:cNvSpPr txBox="1"/>
           <p:nvPr/>
         </p:nvSpPr>
@@ -4022,7 +4086,7 @@
       </p:sp>
       <p:sp>
         <p:nvSpPr>
-          <p:cNvPr id="5" name="TextBox 4"/>
+          <p:cNvPr id="6" name="TextBox 5"/>
           <p:cNvSpPr txBox="1"/>
           <p:nvPr/>
         </p:nvSpPr>
@@ -4056,7 +4120,7 @@
       </p:sp>
       <p:sp>
         <p:nvSpPr>
-          <p:cNvPr id="6" name="TextBox 5"/>
+          <p:cNvPr id="7" name="TextBox 6"/>
           <p:cNvSpPr txBox="1"/>
           <p:nvPr/>
         </p:nvSpPr>
@@ -4102,14 +4166,6 @@
 <file path=ppt/slides/slide5.xml><?xml version="1.0" encoding="utf-8"?>
 <p:sld xmlns:a="http://schemas.openxmlformats.org/drawingml/2006/main" xmlns:p="http://schemas.openxmlformats.org/presentationml/2006/main" xmlns:r="http://schemas.openxmlformats.org/officeDocument/2006/relationships">
   <p:cSld>
-    <p:bg>
-      <p:bgPr>
-        <a:solidFill>
-          <a:srgbClr val="12141C"/>
-        </a:solidFill>
-        <a:effectLst/>
-      </p:bgPr>
-    </p:bg>
     <p:spTree>
       <p:nvGrpSpPr>
         <p:cNvPr id="1" name=""/>
@@ -4117,9 +4173,33 @@
         <p:nvPr/>
       </p:nvGrpSpPr>
       <p:grpSpPr/>
-      <p:sp>
-        <p:nvSpPr>
-          <p:cNvPr id="2" name="TextBox 1"/>
+      <p:pic>
+        <p:nvPicPr>
+          <p:cNvPr id="2" name="Picture 1" descr="onyx-gold_content.png"/>
+          <p:cNvPicPr>
+            <a:picLocks noChangeAspect="1"/>
+          </p:cNvPicPr>
+          <p:nvPr/>
+        </p:nvPicPr>
+        <p:blipFill>
+          <a:blip r:embed="rId2"/>
+          <a:stretch>
+            <a:fillRect/>
+          </a:stretch>
+        </p:blipFill>
+        <p:spPr>
+          <a:xfrm>
+            <a:off x="0" y="0"/>
+            <a:ext cx="12191695" cy="6858000"/>
+          </a:xfrm>
+          <a:prstGeom prst="rect">
+            <a:avLst/>
+          </a:prstGeom>
+        </p:spPr>
+      </p:pic>
+      <p:sp>
+        <p:nvSpPr>
+          <p:cNvPr id="3" name="TextBox 2"/>
           <p:cNvSpPr txBox="1"/>
           <p:nvPr/>
         </p:nvSpPr>
@@ -4153,7 +4233,7 @@
       </p:sp>
       <p:sp>
         <p:nvSpPr>
-          <p:cNvPr id="3" name="Rectangle 2"/>
+          <p:cNvPr id="4" name="Rectangle 3"/>
           <p:cNvSpPr/>
           <p:nvPr/>
         </p:nvSpPr>
@@ -4197,7 +4277,7 @@
       </p:sp>
       <p:graphicFrame>
         <p:nvGraphicFramePr>
-          <p:cNvPr id="4" name="Table 3"/>
+          <p:cNvPr id="5" name="Table 4"/>
           <p:cNvGraphicFramePr>
             <a:graphicFrameLocks noGrp="1"/>
           </p:cNvGraphicFramePr>
@@ -4427,7 +4507,7 @@
                   </a:txBody>
                   <a:tcPr>
                     <a:solidFill>
-                      <a:srgbClr val="1B1E2B"/>
+                      <a:srgbClr val="1E2233"/>
                     </a:solidFill>
                   </a:tcPr>
                 </a:tc>
@@ -4450,7 +4530,7 @@
                   </a:txBody>
                   <a:tcPr>
                     <a:solidFill>
-                      <a:srgbClr val="1B1E2B"/>
+                      <a:srgbClr val="1E2233"/>
                     </a:solidFill>
                   </a:tcPr>
                 </a:tc>
@@ -4473,7 +4553,7 @@
                   </a:txBody>
                   <a:tcPr>
                     <a:solidFill>
-                      <a:srgbClr val="1B1E2B"/>
+                      <a:srgbClr val="1E2233"/>
                     </a:solidFill>
                   </a:tcPr>
                 </a:tc>
@@ -4496,7 +4576,7 @@
                   </a:txBody>
                   <a:tcPr>
                     <a:solidFill>
-                      <a:srgbClr val="1B1E2B"/>
+                      <a:srgbClr val="1E2233"/>
                     </a:solidFill>
                   </a:tcPr>
                 </a:tc>
@@ -4601,7 +4681,7 @@
       </p:graphicFrame>
       <p:sp>
         <p:nvSpPr>
-          <p:cNvPr id="5" name="TextBox 4"/>
+          <p:cNvPr id="6" name="TextBox 5"/>
           <p:cNvSpPr txBox="1"/>
           <p:nvPr/>
         </p:nvSpPr>
@@ -4635,7 +4715,7 @@
       </p:sp>
       <p:sp>
         <p:nvSpPr>
-          <p:cNvPr id="6" name="TextBox 5"/>
+          <p:cNvPr id="7" name="TextBox 6"/>
           <p:cNvSpPr txBox="1"/>
           <p:nvPr/>
         </p:nvSpPr>
@@ -4681,14 +4761,6 @@
 <file path=ppt/slides/slide6.xml><?xml version="1.0" encoding="utf-8"?>
 <p:sld xmlns:a="http://schemas.openxmlformats.org/drawingml/2006/main" xmlns:p="http://schemas.openxmlformats.org/presentationml/2006/main" xmlns:r="http://schemas.openxmlformats.org/officeDocument/2006/relationships">
   <p:cSld>
-    <p:bg>
-      <p:bgPr>
-        <a:solidFill>
-          <a:srgbClr val="1B1E2B"/>
-        </a:solidFill>
-        <a:effectLst/>
-      </p:bgPr>
-    </p:bg>
     <p:spTree>
       <p:nvGrpSpPr>
         <p:cNvPr id="1" name=""/>
@@ -4696,9 +4768,33 @@
         <p:nvPr/>
       </p:nvGrpSpPr>
       <p:grpSpPr/>
-      <p:sp>
-        <p:nvSpPr>
-          <p:cNvPr id="2" name="TextBox 1"/>
+      <p:pic>
+        <p:nvPicPr>
+          <p:cNvPr id="2" name="Picture 1" descr="onyx-gold_content.png"/>
+          <p:cNvPicPr>
+            <a:picLocks noChangeAspect="1"/>
+          </p:cNvPicPr>
+          <p:nvPr/>
+        </p:nvPicPr>
+        <p:blipFill>
+          <a:blip r:embed="rId2"/>
+          <a:stretch>
+            <a:fillRect/>
+          </a:stretch>
+        </p:blipFill>
+        <p:spPr>
+          <a:xfrm>
+            <a:off x="0" y="0"/>
+            <a:ext cx="12191695" cy="6858000"/>
+          </a:xfrm>
+          <a:prstGeom prst="rect">
+            <a:avLst/>
+          </a:prstGeom>
+        </p:spPr>
+      </p:pic>
+      <p:sp>
+        <p:nvSpPr>
+          <p:cNvPr id="3" name="TextBox 2"/>
           <p:cNvSpPr txBox="1"/>
           <p:nvPr/>
         </p:nvSpPr>
@@ -4732,7 +4828,7 @@
       </p:sp>
       <p:sp>
         <p:nvSpPr>
-          <p:cNvPr id="3" name="TextBox 2"/>
+          <p:cNvPr id="4" name="TextBox 3"/>
           <p:cNvSpPr txBox="1"/>
           <p:nvPr/>
         </p:nvSpPr>
@@ -4766,7 +4862,7 @@
       </p:sp>
       <p:sp>
         <p:nvSpPr>
-          <p:cNvPr id="4" name="TextBox 3"/>
+          <p:cNvPr id="5" name="TextBox 4"/>
           <p:cNvSpPr txBox="1"/>
           <p:nvPr/>
         </p:nvSpPr>
@@ -4800,7 +4896,7 @@
       </p:sp>
       <p:sp>
         <p:nvSpPr>
-          <p:cNvPr id="5" name="TextBox 4"/>
+          <p:cNvPr id="6" name="TextBox 5"/>
           <p:cNvSpPr txBox="1"/>
           <p:nvPr/>
         </p:nvSpPr>
@@ -4846,14 +4942,6 @@
 <file path=ppt/slides/slide7.xml><?xml version="1.0" encoding="utf-8"?>
 <p:sld xmlns:a="http://schemas.openxmlformats.org/drawingml/2006/main" xmlns:p="http://schemas.openxmlformats.org/presentationml/2006/main" xmlns:r="http://schemas.openxmlformats.org/officeDocument/2006/relationships">
   <p:cSld>
-    <p:bg>
-      <p:bgPr>
-        <a:solidFill>
-          <a:srgbClr val="1B1E2B"/>
-        </a:solidFill>
-        <a:effectLst/>
-      </p:bgPr>
-    </p:bg>
     <p:spTree>
       <p:nvGrpSpPr>
         <p:cNvPr id="1" name=""/>
@@ -4861,9 +4949,33 @@
         <p:nvPr/>
       </p:nvGrpSpPr>
       <p:grpSpPr/>
-      <p:sp>
-        <p:nvSpPr>
-          <p:cNvPr id="2" name="TextBox 1"/>
+      <p:pic>
+        <p:nvPicPr>
+          <p:cNvPr id="2" name="Picture 1" descr="onyx-gold_hero.png"/>
+          <p:cNvPicPr>
+            <a:picLocks noChangeAspect="1"/>
+          </p:cNvPicPr>
+          <p:nvPr/>
+        </p:nvPicPr>
+        <p:blipFill>
+          <a:blip r:embed="rId2"/>
+          <a:stretch>
+            <a:fillRect/>
+          </a:stretch>
+        </p:blipFill>
+        <p:spPr>
+          <a:xfrm>
+            <a:off x="0" y="0"/>
+            <a:ext cx="12191695" cy="6858000"/>
+          </a:xfrm>
+          <a:prstGeom prst="rect">
+            <a:avLst/>
+          </a:prstGeom>
+        </p:spPr>
+      </p:pic>
+      <p:sp>
+        <p:nvSpPr>
+          <p:cNvPr id="3" name="TextBox 2"/>
           <p:cNvSpPr txBox="1"/>
           <p:nvPr/>
         </p:nvSpPr>
@@ -4897,7 +5009,7 @@
       </p:sp>
       <p:sp>
         <p:nvSpPr>
-          <p:cNvPr id="3" name="TextBox 2"/>
+          <p:cNvPr id="4" name="TextBox 3"/>
           <p:cNvSpPr txBox="1"/>
           <p:nvPr/>
         </p:nvSpPr>
@@ -4931,7 +5043,7 @@
       </p:sp>
       <p:sp>
         <p:nvSpPr>
-          <p:cNvPr id="4" name="TextBox 3"/>
+          <p:cNvPr id="5" name="TextBox 4"/>
           <p:cNvSpPr txBox="1"/>
           <p:nvPr/>
         </p:nvSpPr>
@@ -4965,7 +5077,7 @@
       </p:sp>
       <p:sp>
         <p:nvSpPr>
-          <p:cNvPr id="5" name="TextBox 4"/>
+          <p:cNvPr id="6" name="TextBox 5"/>
           <p:cNvSpPr txBox="1"/>
           <p:nvPr/>
         </p:nvSpPr>
@@ -5011,14 +5123,6 @@
 <file path=ppt/slides/slide8.xml><?xml version="1.0" encoding="utf-8"?>
 <p:sld xmlns:a="http://schemas.openxmlformats.org/drawingml/2006/main" xmlns:p="http://schemas.openxmlformats.org/presentationml/2006/main" xmlns:r="http://schemas.openxmlformats.org/officeDocument/2006/relationships">
   <p:cSld>
-    <p:bg>
-      <p:bgPr>
-        <a:solidFill>
-          <a:srgbClr val="12141C"/>
-        </a:solidFill>
-        <a:effectLst/>
-      </p:bgPr>
-    </p:bg>
     <p:spTree>
       <p:nvGrpSpPr>
         <p:cNvPr id="1" name=""/>
@@ -5026,9 +5130,33 @@
         <p:nvPr/>
       </p:nvGrpSpPr>
       <p:grpSpPr/>
-      <p:sp>
-        <p:nvSpPr>
-          <p:cNvPr id="2" name="TextBox 1"/>
+      <p:pic>
+        <p:nvPicPr>
+          <p:cNvPr id="2" name="Picture 1" descr="onyx-gold_content.png"/>
+          <p:cNvPicPr>
+            <a:picLocks noChangeAspect="1"/>
+          </p:cNvPicPr>
+          <p:nvPr/>
+        </p:nvPicPr>
+        <p:blipFill>
+          <a:blip r:embed="rId2"/>
+          <a:stretch>
+            <a:fillRect/>
+          </a:stretch>
+        </p:blipFill>
+        <p:spPr>
+          <a:xfrm>
+            <a:off x="0" y="0"/>
+            <a:ext cx="12191695" cy="6858000"/>
+          </a:xfrm>
+          <a:prstGeom prst="rect">
+            <a:avLst/>
+          </a:prstGeom>
+        </p:spPr>
+      </p:pic>
+      <p:sp>
+        <p:nvSpPr>
+          <p:cNvPr id="3" name="TextBox 2"/>
           <p:cNvSpPr txBox="1"/>
           <p:nvPr/>
         </p:nvSpPr>
@@ -5062,7 +5190,7 @@
       </p:sp>
       <p:sp>
         <p:nvSpPr>
-          <p:cNvPr id="3" name="Rectangle 2"/>
+          <p:cNvPr id="4" name="Rectangle 3"/>
           <p:cNvSpPr/>
           <p:nvPr/>
         </p:nvSpPr>
@@ -5106,7 +5234,7 @@
       </p:sp>
       <p:sp>
         <p:nvSpPr>
-          <p:cNvPr id="4" name="TextBox 3"/>
+          <p:cNvPr id="5" name="TextBox 4"/>
           <p:cNvSpPr txBox="1"/>
           <p:nvPr/>
         </p:nvSpPr>
@@ -5225,7 +5353,7 @@
       </p:sp>
       <p:sp>
         <p:nvSpPr>
-          <p:cNvPr id="5" name="TextBox 4"/>
+          <p:cNvPr id="6" name="TextBox 5"/>
           <p:cNvSpPr txBox="1"/>
           <p:nvPr/>
         </p:nvSpPr>
@@ -5259,7 +5387,7 @@
       </p:sp>
       <p:sp>
         <p:nvSpPr>
-          <p:cNvPr id="6" name="TextBox 5"/>
+          <p:cNvPr id="7" name="TextBox 6"/>
           <p:cNvSpPr txBox="1"/>
           <p:nvPr/>
         </p:nvSpPr>
@@ -5305,14 +5433,6 @@
 <file path=ppt/slides/slide9.xml><?xml version="1.0" encoding="utf-8"?>
 <p:sld xmlns:a="http://schemas.openxmlformats.org/drawingml/2006/main" xmlns:p="http://schemas.openxmlformats.org/presentationml/2006/main" xmlns:r="http://schemas.openxmlformats.org/officeDocument/2006/relationships">
   <p:cSld>
-    <p:bg>
-      <p:bgPr>
-        <a:solidFill>
-          <a:srgbClr val="12141C"/>
-        </a:solidFill>
-        <a:effectLst/>
-      </p:bgPr>
-    </p:bg>
     <p:spTree>
       <p:nvGrpSpPr>
         <p:cNvPr id="1" name=""/>
@@ -5320,9 +5440,33 @@
         <p:nvPr/>
       </p:nvGrpSpPr>
       <p:grpSpPr/>
-      <p:sp>
-        <p:nvSpPr>
-          <p:cNvPr id="2" name="TextBox 1"/>
+      <p:pic>
+        <p:nvPicPr>
+          <p:cNvPr id="2" name="Picture 1" descr="onyx-gold_hero.png"/>
+          <p:cNvPicPr>
+            <a:picLocks noChangeAspect="1"/>
+          </p:cNvPicPr>
+          <p:nvPr/>
+        </p:nvPicPr>
+        <p:blipFill>
+          <a:blip r:embed="rId2"/>
+          <a:stretch>
+            <a:fillRect/>
+          </a:stretch>
+        </p:blipFill>
+        <p:spPr>
+          <a:xfrm>
+            <a:off x="0" y="0"/>
+            <a:ext cx="12191695" cy="6858000"/>
+          </a:xfrm>
+          <a:prstGeom prst="rect">
+            <a:avLst/>
+          </a:prstGeom>
+        </p:spPr>
+      </p:pic>
+      <p:sp>
+        <p:nvSpPr>
+          <p:cNvPr id="3" name="TextBox 2"/>
           <p:cNvSpPr txBox="1"/>
           <p:nvPr/>
         </p:nvSpPr>
@@ -5356,7 +5500,7 @@
       </p:sp>
       <p:sp>
         <p:nvSpPr>
-          <p:cNvPr id="3" name="TextBox 2"/>
+          <p:cNvPr id="4" name="TextBox 3"/>
           <p:cNvSpPr txBox="1"/>
           <p:nvPr/>
         </p:nvSpPr>
@@ -5390,7 +5534,7 @@
       </p:sp>
       <p:sp>
         <p:nvSpPr>
-          <p:cNvPr id="4" name="Rectangle 3"/>
+          <p:cNvPr id="5" name="Rectangle 4"/>
           <p:cNvSpPr/>
           <p:nvPr/>
         </p:nvSpPr>
@@ -5434,7 +5578,7 @@
       </p:sp>
       <p:sp>
         <p:nvSpPr>
-          <p:cNvPr id="5" name="TextBox 4"/>
+          <p:cNvPr id="6" name="TextBox 5"/>
           <p:cNvSpPr txBox="1"/>
           <p:nvPr/>
         </p:nvSpPr>
@@ -5468,7 +5612,7 @@
       </p:sp>
       <p:sp>
         <p:nvSpPr>
-          <p:cNvPr id="6" name="TextBox 5"/>
+          <p:cNvPr id="7" name="TextBox 6"/>
           <p:cNvSpPr txBox="1"/>
           <p:nvPr/>
         </p:nvSpPr>

</xml_diff>